<commit_message>
Services engagements below target; under budget flagged like over; Export menu without Copy a link
- Three September services engagements below the 40% target (reasons in financial_model.py); all CSVs, schema,
  table guide, Power BI prompts and downloads rebuilt from the model.
- Grant budget chart: off budget either way is red, within 1% amber (site, PDF, PowerPoint).
- Export menu: Copy a link row removed sitewide, menu narrower; the hero's menu opens upwards and nothing clips it.

Co-Authored-By: Claude Opus 5.5 <noreply@anthropic.com>
</commit_message>
<xml_diff>
--- a/media/exports/nfp-sample-statements.pptx
+++ b/media/exports/nfp-sample-statements.pptx
@@ -147,7 +147,7 @@
             <c:idx val="0"/>
             <c:spPr>
               <a:solidFill>
-                <a:srgbClr val="7D8790"/>
+                <a:srgbClr val="B42318"/>
               </a:solidFill>
             </c:spPr>
           </c:dPt>
@@ -155,7 +155,7 @@
             <c:idx val="1"/>
             <c:spPr>
               <a:solidFill>
-                <a:srgbClr val="7D8790"/>
+                <a:srgbClr val="B42318"/>
               </a:solidFill>
             </c:spPr>
           </c:dPt>
@@ -163,7 +163,7 @@
             <c:idx val="2"/>
             <c:spPr>
               <a:solidFill>
-                <a:srgbClr val="7D8790"/>
+                <a:srgbClr val="8A6D3B"/>
               </a:solidFill>
             </c:spPr>
           </c:dPt>
@@ -359,7 +359,7 @@
             <c:idx val="0"/>
             <c:spPr>
               <a:solidFill>
-                <a:srgbClr val="7D8790"/>
+                <a:srgbClr val="B42318"/>
               </a:solidFill>
             </c:spPr>
           </c:dPt>
@@ -367,7 +367,7 @@
             <c:idx val="1"/>
             <c:spPr>
               <a:solidFill>
-                <a:srgbClr val="7D8790"/>
+                <a:srgbClr val="B42318"/>
               </a:solidFill>
             </c:spPr>
           </c:dPt>
@@ -375,7 +375,7 @@
             <c:idx val="2"/>
             <c:spPr>
               <a:solidFill>
-                <a:srgbClr val="7D8790"/>
+                <a:srgbClr val="8A6D3B"/>
               </a:solidFill>
             </c:spPr>
           </c:dPt>
@@ -12997,7 +12997,7 @@
                 </a:solidFill>
                 <a:latin typeface="Roboto"/>
               </a:rPr>
-              <a:t>Spending to date against budget to date (the grant spread evenly over its months). Over budget in red; under budget in grey.</a:t>
+              <a:t>Spending to date against budget to date (the grant spread evenly over its months). Over or under budget in red; within 1% in amber.</a:t>
             </a:r>
           </a:p>
         </p:txBody>
@@ -13314,7 +13314,7 @@
                 </a:solidFill>
                 <a:latin typeface="Roboto"/>
               </a:rPr>
-              <a:t>Spending to date against budget to date (the grant spread evenly over its months). Over budget in red; under budget in grey.</a:t>
+              <a:t>Spending to date against budget to date (the grant spread evenly over its months). Over or under budget in red; within 1% in amber.</a:t>
             </a:r>
           </a:p>
         </p:txBody>

</xml_diff>

<commit_message>
Budget colours: over red, under green, within 1% amber (site, PDF, Excel, PowerPoint, board table)
Co-Authored-By: Claude Opus 5.5 <noreply@anthropic.com>
</commit_message>
<xml_diff>
--- a/media/exports/nfp-sample-statements.pptx
+++ b/media/exports/nfp-sample-statements.pptx
@@ -160,7 +160,7 @@
             <c:idx val="0"/>
             <c:spPr>
               <a:solidFill>
-                <a:srgbClr val="B42318"/>
+                <a:srgbClr val="0E9F6E"/>
               </a:solidFill>
             </c:spPr>
           </c:dPt>
@@ -168,7 +168,7 @@
             <c:idx val="1"/>
             <c:spPr>
               <a:solidFill>
-                <a:srgbClr val="B42318"/>
+                <a:srgbClr val="0E9F6E"/>
               </a:solidFill>
             </c:spPr>
           </c:dPt>
@@ -386,7 +386,7 @@
             <c:idx val="0"/>
             <c:spPr>
               <a:solidFill>
-                <a:srgbClr val="B42318"/>
+                <a:srgbClr val="0E9F6E"/>
               </a:solidFill>
             </c:spPr>
           </c:dPt>
@@ -394,7 +394,7 @@
             <c:idx val="1"/>
             <c:spPr>
               <a:solidFill>
-                <a:srgbClr val="B42318"/>
+                <a:srgbClr val="0E9F6E"/>
               </a:solidFill>
             </c:spPr>
           </c:dPt>
@@ -1599,7 +1599,7 @@
           <a:lstStyle/>
           <a:p>
             <a:r>
-              <a:t>Each grant: over or under budget to 30 September 2026. % of budget · Spending to date against budget to date (the grant spread evenly over its months). Over or under budget in red; within 1% in amber.</a:t>
+              <a:t>Each grant: over or under budget to 30 September 2026. % of budget · Spending to date against budget to date (the grant spread evenly over its months). Over budget in red, under budget in green; within 1% in amber.</a:t>
             </a:r>
           </a:p>
         </p:txBody>
@@ -1669,7 +1669,7 @@
           <a:lstStyle/>
           <a:p>
             <a:r>
-              <a:t>Each grant: over or under budget to 30 September 2026. $ · Spending to date against budget to date (the grant spread evenly over its months). Over or under budget in red; within 1% in amber.</a:t>
+              <a:t>Each grant: over or under budget to 30 September 2026. $ · Spending to date against budget to date (the grant spread evenly over its months). Over budget in red, under budget in green; within 1% in amber.</a:t>
             </a:r>
           </a:p>
         </p:txBody>
@@ -5434,7 +5434,7 @@
                 </a:solidFill>
                 <a:latin typeface="Roboto"/>
               </a:rPr>
-              <a:t>Data retrieved 2pm, Tue 6 Oct 2026 · Generated 8 Oct 2026, 9:35am · Sample data · Made with Python (python-pptx)</a:t>
+              <a:t>Data retrieved 2pm, Tue 6 Oct 2026 · Generated 8 Oct 2026, 10:34am · Sample data · Made with Python (python-pptx)</a:t>
             </a:r>
           </a:p>
         </p:txBody>
@@ -7260,7 +7260,7 @@
                 </a:solidFill>
                 <a:latin typeface="Roboto"/>
               </a:rPr>
-              <a:t>Data retrieved 2pm, Tue 6 Oct 2026 · Generated 8 Oct 2026, 9:35am · Sample data · Made with Python (python-pptx)</a:t>
+              <a:t>Data retrieved 2pm, Tue 6 Oct 2026 · Generated 8 Oct 2026, 10:34am · Sample data · Made with Python (python-pptx)</a:t>
             </a:r>
           </a:p>
         </p:txBody>
@@ -8976,7 +8976,7 @@
                 </a:solidFill>
                 <a:latin typeface="Roboto"/>
               </a:rPr>
-              <a:t>Data retrieved 2pm, Tue 6 Oct 2026 · Generated 8 Oct 2026, 9:35am · Sample data · Made with Python (python-pptx)</a:t>
+              <a:t>Data retrieved 2pm, Tue 6 Oct 2026 · Generated 8 Oct 2026, 10:34am · Sample data · Made with Python (python-pptx)</a:t>
             </a:r>
           </a:p>
         </p:txBody>
@@ -11742,7 +11742,7 @@
                 </a:solidFill>
                 <a:latin typeface="Roboto"/>
               </a:rPr>
-              <a:t>Data retrieved 2pm, Tue 6 Oct 2026 · Generated 8 Oct 2026, 9:35am · Sample data · Made with Python (python-pptx)</a:t>
+              <a:t>Data retrieved 2pm, Tue 6 Oct 2026 · Generated 8 Oct 2026, 10:34am · Sample data · Made with Python (python-pptx)</a:t>
             </a:r>
           </a:p>
         </p:txBody>
@@ -12194,7 +12194,7 @@
                 </a:solidFill>
                 <a:latin typeface="Roboto"/>
               </a:rPr>
-              <a:t>Data retrieved 2pm, Tue 6 Oct 2026 · Generated 8 Oct 2026, 9:35am · Sample data · Made with Python (python-pptx)</a:t>
+              <a:t>Data retrieved 2pm, Tue 6 Oct 2026 · Generated 8 Oct 2026, 10:34am · Sample data · Made with Python (python-pptx)</a:t>
             </a:r>
           </a:p>
         </p:txBody>
@@ -12926,7 +12926,7 @@
                 </a:solidFill>
                 <a:latin typeface="Roboto"/>
               </a:rPr>
-              <a:t>Data retrieved 2pm, Tue 6 Oct 2026 · Generated 8 Oct 2026, 9:35am · Sample data · Made with Python (python-pptx)</a:t>
+              <a:t>Data retrieved 2pm, Tue 6 Oct 2026 · Generated 8 Oct 2026, 10:34am · Sample data · Made with Python (python-pptx)</a:t>
             </a:r>
           </a:p>
         </p:txBody>
@@ -13434,7 +13434,7 @@
                 </a:solidFill>
                 <a:latin typeface="Roboto"/>
               </a:rPr>
-              <a:t>Data retrieved 2pm, Tue 6 Oct 2026 · Generated 8 Oct 2026, 9:35am · Sample data · Made with Python (python-pptx)</a:t>
+              <a:t>Data retrieved 2pm, Tue 6 Oct 2026 · Generated 8 Oct 2026, 10:34am · Sample data · Made with Python (python-pptx)</a:t>
             </a:r>
           </a:p>
         </p:txBody>
@@ -13998,7 +13998,7 @@
                 </a:solidFill>
                 <a:latin typeface="Roboto"/>
               </a:rPr>
-              <a:t>Data retrieved 2pm, Tue 6 Oct 2026 · Generated 8 Oct 2026, 9:35am · Sample data · Made with Python (python-pptx)</a:t>
+              <a:t>Data retrieved 2pm, Tue 6 Oct 2026 · Generated 8 Oct 2026, 10:34am · Sample data · Made with Python (python-pptx)</a:t>
             </a:r>
           </a:p>
         </p:txBody>
@@ -14754,7 +14754,7 @@
                 </a:solidFill>
                 <a:latin typeface="Roboto"/>
               </a:rPr>
-              <a:t>Data retrieved 2pm, Tue 6 Oct 2026 · Generated 8 Oct 2026, 9:35am · Sample data · Made with Python (python-pptx)</a:t>
+              <a:t>Data retrieved 2pm, Tue 6 Oct 2026 · Generated 8 Oct 2026, 10:34am · Sample data · Made with Python (python-pptx)</a:t>
             </a:r>
           </a:p>
         </p:txBody>
@@ -14948,7 +14948,7 @@
         <p:spPr>
           <a:xfrm>
             <a:off x="457200" y="914400"/>
-            <a:ext cx="11277295" cy="263652"/>
+            <a:ext cx="11277295" cy="454152"/>
           </a:xfrm>
           <a:prstGeom prst="rect">
             <a:avLst/>
@@ -14973,7 +14973,7 @@
                 </a:solidFill>
                 <a:latin typeface="Roboto"/>
               </a:rPr>
-              <a:t>% of budget · Spending to date against budget to date (the grant spread evenly over its months). Over or under budget in red; within 1% in amber.</a:t>
+              <a:t>% of budget · Spending to date against budget to date (the grant spread evenly over its months). Over budget in red, under budget in green; within 1% in amber.</a:t>
             </a:r>
           </a:p>
         </p:txBody>
@@ -14987,8 +14987,8 @@
           <p:nvPr/>
         </p:nvGraphicFramePr>
         <p:xfrm>
-          <a:off x="457200" y="1278636"/>
-          <a:ext cx="11277295" cy="4527804"/>
+          <a:off x="457200" y="1469136"/>
+          <a:ext cx="11277295" cy="4337304"/>
         </p:xfrm>
         <a:graphic>
           <a:graphicData uri="http://schemas.openxmlformats.org/drawingml/2006/chart">
@@ -15069,7 +15069,7 @@
                 </a:solidFill>
                 <a:latin typeface="Roboto"/>
               </a:rPr>
-              <a:t>Data retrieved 2pm, Tue 6 Oct 2026 · Generated 8 Oct 2026, 9:35am · Sample data · Made with Python (python-pptx)</a:t>
+              <a:t>Data retrieved 2pm, Tue 6 Oct 2026 · Generated 8 Oct 2026, 10:34am · Sample data · Made with Python (python-pptx)</a:t>
             </a:r>
           </a:p>
         </p:txBody>
@@ -15263,7 +15263,7 @@
         <p:spPr>
           <a:xfrm>
             <a:off x="457200" y="914400"/>
-            <a:ext cx="11277295" cy="263652"/>
+            <a:ext cx="11277295" cy="454152"/>
           </a:xfrm>
           <a:prstGeom prst="rect">
             <a:avLst/>
@@ -15288,7 +15288,7 @@
                 </a:solidFill>
                 <a:latin typeface="Roboto"/>
               </a:rPr>
-              <a:t>$ · Spending to date against budget to date (the grant spread evenly over its months). Over or under budget in red; within 1% in amber.</a:t>
+              <a:t>$ · Spending to date against budget to date (the grant spread evenly over its months). Over budget in red, under budget in green; within 1% in amber.</a:t>
             </a:r>
           </a:p>
         </p:txBody>
@@ -15302,8 +15302,8 @@
           <p:nvPr/>
         </p:nvGraphicFramePr>
         <p:xfrm>
-          <a:off x="457200" y="1278636"/>
-          <a:ext cx="11277295" cy="4527804"/>
+          <a:off x="457200" y="1469136"/>
+          <a:ext cx="11277295" cy="4337304"/>
         </p:xfrm>
         <a:graphic>
           <a:graphicData uri="http://schemas.openxmlformats.org/drawingml/2006/chart">
@@ -15384,7 +15384,7 @@
                 </a:solidFill>
                 <a:latin typeface="Roboto"/>
               </a:rPr>
-              <a:t>Data retrieved 2pm, Tue 6 Oct 2026 · Generated 8 Oct 2026, 9:35am · Sample data · Made with Python (python-pptx)</a:t>
+              <a:t>Data retrieved 2pm, Tue 6 Oct 2026 · Generated 8 Oct 2026, 10:34am · Sample data · Made with Python (python-pptx)</a:t>
             </a:r>
           </a:p>
         </p:txBody>
@@ -16529,7 +16529,7 @@
                 </a:solidFill>
                 <a:latin typeface="Roboto"/>
               </a:rPr>
-              <a:t>Data retrieved 2pm, Tue 6 Oct 2026 · Generated 8 Oct 2026, 9:35am · Sample data · Made with Python (python-pptx)</a:t>
+              <a:t>Data retrieved 2pm, Tue 6 Oct 2026 · Generated 8 Oct 2026, 10:34am · Sample data · Made with Python (python-pptx)</a:t>
             </a:r>
           </a:p>
         </p:txBody>
@@ -17342,7 +17342,7 @@
                 </a:solidFill>
                 <a:latin typeface="Roboto"/>
               </a:rPr>
-              <a:t>Data retrieved 2pm, Tue 6 Oct 2026 · Generated 8 Oct 2026, 9:35am · Sample data · Made with Python (python-pptx)</a:t>
+              <a:t>Data retrieved 2pm, Tue 6 Oct 2026 · Generated 8 Oct 2026, 10:34am · Sample data · Made with Python (python-pptx)</a:t>
             </a:r>
           </a:p>
         </p:txBody>
@@ -17880,7 +17880,7 @@
                 </a:solidFill>
                 <a:latin typeface="Roboto"/>
               </a:rPr>
-              <a:t>Data retrieved 2pm, Tue 6 Oct 2026 · Generated 8 Oct 2026, 9:35am · Sample data · Made with Python (python-pptx)</a:t>
+              <a:t>Data retrieved 2pm, Tue 6 Oct 2026 · Generated 8 Oct 2026, 10:34am · Sample data · Made with Python (python-pptx)</a:t>
             </a:r>
           </a:p>
         </p:txBody>
@@ -19816,7 +19816,7 @@
                 </a:solidFill>
                 <a:latin typeface="Roboto"/>
               </a:rPr>
-              <a:t>Data retrieved 2pm, Tue 6 Oct 2026 · Generated 8 Oct 2026, 9:35am · Sample data · Made with Python (python-pptx)</a:t>
+              <a:t>Data retrieved 2pm, Tue 6 Oct 2026 · Generated 8 Oct 2026, 10:34am · Sample data · Made with Python (python-pptx)</a:t>
             </a:r>
           </a:p>
         </p:txBody>
@@ -21642,7 +21642,7 @@
                 </a:solidFill>
                 <a:latin typeface="Roboto"/>
               </a:rPr>
-              <a:t>Data retrieved 2pm, Tue 6 Oct 2026 · Generated 8 Oct 2026, 9:35am · Sample data · Made with Python (python-pptx)</a:t>
+              <a:t>Data retrieved 2pm, Tue 6 Oct 2026 · Generated 8 Oct 2026, 10:34am · Sample data · Made with Python (python-pptx)</a:t>
             </a:r>
           </a:p>
         </p:txBody>

</xml_diff>